<commit_message>
Replace demos 06-10 with real plugin-grounded workflows (AuthMatrix, ParamFinder, archive recon, gRPC/protobuf, GraphQL)
</commit_message>
<xml_diff>
--- a/slides/your-ai-needs-a-proxy.pptx
+++ b/slides/your-ai-needs-a-proxy.pptx
@@ -1584,7 +1584,7 @@
           <a:p>
             <a:r>
               <a:rPr lang="en-US" dirty="0"/>
-              <a:t>Death by tedium manually; seconds here. The demo that earns its keep.</a:t>
+              <a:t>Plugin does the deterministic replay; AI makes the semantic call. The division of labor is the whole philosophy.</a:t>
             </a:r>
             <a:endParaRPr lang="en-US" dirty="0"/>
           </a:p>
@@ -1672,7 +1672,7 @@
           <a:p>
             <a:r>
               <a:rPr lang="en-US" dirty="0"/>
-              <a:t>We weaponize the skill we just built.</a:t>
+              <a:t>Discovery plus instant impact testing. Finding ?url is nothing until the SSRF watcher lights up.</a:t>
             </a:r>
             <a:endParaRPr lang="en-US" dirty="0"/>
           </a:p>
@@ -1760,7 +1760,7 @@
           <a:p>
             <a:r>
               <a:rPr lang="en-US" dirty="0"/>
-              <a:t>Proven tool + smart driver. Only on test accounts you own.</a:t>
+              <a:t>The archive remembers the URLs they meant to delete. Triage at scale is the AI's job.</a:t>
             </a:r>
             <a:endParaRPr lang="en-US" dirty="0"/>
           </a:p>
@@ -1848,7 +1848,7 @@
           <a:p>
             <a:r>
               <a:rPr lang="en-US" dirty="0"/>
-              <a:t>Reading the client is the highest-leverage recon — privilege escalation.</a:t>
+              <a:t>The genuinely hard one. You can't fuzz what you can't read; the AI reads the JS. This is the hack-Google technique.</a:t>
             </a:r>
             <a:endParaRPr lang="en-US" dirty="0"/>
           </a:p>
@@ -1936,7 +1936,7 @@
           <a:p>
             <a:r>
               <a:rPr lang="en-US" dirty="0"/>
-              <a:t>The hack-Google trick. Explore with AI, harden into a tool.</a:t>
+              <a:t>One endpoint, a thousand-type schema. Plugin draws the map; AI finds the dangerous operations.</a:t>
             </a:r>
             <a:endParaRPr lang="en-US" dirty="0"/>
           </a:p>
@@ -8181,7 +8181,7 @@
                 <a:ea typeface="Calibri" pitchFamily="34" charset="-122"/>
                 <a:cs typeface="Calibri" pitchFamily="34" charset="-120"/>
               </a:rPr>
-              <a:t>DEMO 06</a:t>
+              <a:t>DEMO 06 · AUTHMATRIX</a:t>
             </a:r>
             <a:endParaRPr lang="en-US" sz="1200" dirty="0"/>
           </a:p>
@@ -8281,7 +8281,7 @@
                 <a:ea typeface="Century Schoolbook" pitchFamily="34" charset="-122"/>
                 <a:cs typeface="Century Schoolbook" pitchFamily="34" charset="-120"/>
               </a:rPr>
-              <a:t>IDOR / BOLA matrix</a:t>
+              <a:t>Authorization testing (BOLA / BFLA)</a:t>
             </a:r>
             <a:endParaRPr lang="en-US" sz="3000" dirty="0"/>
           </a:p>
@@ -8324,7 +8324,7 @@
                 <a:ea typeface="Calibri" pitchFamily="34" charset="-122"/>
                 <a:cs typeface="Calibri" pitchFamily="34" charset="-120"/>
               </a:rPr>
-              <a:t>Swap {victim A, attacker B, no-auth} across every object-id endpoint</a:t>
+              <a:t>Plugin replays every request as every user — deterministic grid</a:t>
             </a:r>
             <a:endParaRPr lang="en-US" sz="1500" dirty="0"/>
           </a:p>
@@ -8345,7 +8345,7 @@
                 <a:ea typeface="Calibri" pitchFamily="34" charset="-122"/>
                 <a:cs typeface="Calibri" pitchFamily="34" charset="-120"/>
               </a:rPr>
-              <a:t>caido_batch_send fires the whole matrix in parallel, then diffs responses</a:t>
+              <a:t>AI reads the response bodies and judges real leak vs. legit (the hard part)</a:t>
             </a:r>
             <a:endParaRPr lang="en-US" sz="1500" dirty="0"/>
           </a:p>
@@ -8366,7 +8366,7 @@
                 <a:ea typeface="Calibri" pitchFamily="34" charset="-122"/>
                 <a:cs typeface="Calibri" pitchFamily="34" charset="-120"/>
               </a:rPr>
-              <a:t>Flag any endpoint where B or no-auth returns A's data → OWASP API #1</a:t>
+              <a:t>OWASP API #1 — what no scanner can decide on its own</a:t>
             </a:r>
             <a:endParaRPr lang="en-US" sz="1500" dirty="0"/>
           </a:p>
@@ -8432,7 +8432,7 @@
                 <a:ea typeface="Courier New" pitchFamily="34" charset="-122"/>
                 <a:cs typeface="Courier New" pitchFamily="34" charset="-120"/>
               </a:rPr>
-              <a:t>"…build 3 variants swapping only credentials, send with caido_batch_send, diff vs A, show the verdict table first."</a:t>
+              <a:t>"For each cell where a lower-priv identity got another user's data, compare bodies and decide if it's a real break. Table first."</a:t>
             </a:r>
             <a:endParaRPr lang="en-US" sz="1300" dirty="0"/>
           </a:p>
@@ -8503,7 +8503,7 @@
                 <a:ea typeface="Calibri" pitchFamily="34" charset="-122"/>
                 <a:cs typeface="Calibri" pitchFamily="34" charset="-120"/>
               </a:rPr>
-              <a:t>DEMO 07</a:t>
+              <a:t>DEMO 07 · PARAMFINDER</a:t>
             </a:r>
             <a:endParaRPr lang="en-US" sz="1200" dirty="0"/>
           </a:p>
@@ -8603,7 +8603,7 @@
                 <a:ea typeface="Century Schoolbook" pitchFamily="34" charset="-122"/>
                 <a:cs typeface="Century Schoolbook" pitchFamily="34" charset="-120"/>
               </a:rPr>
-              <a:t>Blind SSRF at scale</a:t>
+              <a:t>Hidden parameter &amp; header mining</a:t>
             </a:r>
             <a:endParaRPr lang="en-US" sz="3000" dirty="0"/>
           </a:p>
@@ -8646,7 +8646,7 @@
                 <a:ea typeface="Calibri" pitchFamily="34" charset="-122"/>
                 <a:cs typeface="Calibri" pitchFamily="34" charset="-120"/>
               </a:rPr>
-              <a:t>Weaponize the skill from demo 05: one OAST canary URL</a:t>
+              <a:t>Plugin brute-forces hidden query/body/header params</a:t>
             </a:r>
             <a:endParaRPr lang="en-US" sz="1500" dirty="0"/>
           </a:p>
@@ -8667,7 +8667,7 @@
                 <a:ea typeface="Calibri" pitchFamily="34" charset="-122"/>
                 <a:cs typeface="Calibri" pitchFamily="34" charset="-120"/>
               </a:rPr>
-              <a:t>Inject it into every url/redirect/webhook/image parameter across traffic</a:t>
+              <a:t>AI triages each: ?url→SSRF, ?file→LFI, ?debug→leak, header→cache poison</a:t>
             </a:r>
             <a:endParaRPr lang="en-US" sz="1500" dirty="0"/>
           </a:p>
@@ -8688,7 +8688,7 @@
                 <a:ea typeface="Calibri" pitchFamily="34" charset="-122"/>
                 <a:cs typeface="Calibri" pitchFamily="34" charset="-120"/>
               </a:rPr>
-              <a:t>Watch callbacks (DNS/HTTP + headers) — a hit you'd never see in a response</a:t>
+              <a:t>then weaponizes with caido_batch_send + the QuickSSRF canary</a:t>
             </a:r>
             <a:endParaRPr lang="en-US" sz="1500" dirty="0"/>
           </a:p>
@@ -8754,7 +8754,7 @@
                 <a:ea typeface="Courier New" pitchFamily="34" charset="-122"/>
                 <a:cs typeface="Courier New" pitchFamily="34" charset="-120"/>
               </a:rPr>
-              <a:t>"Our canary is &lt;oast-url&gt;. Inject into every URL-ish param and send through Caido; tell me which request each came from."</a:t>
+              <a:t>"Read the ParamFinder findings, classify each param's likely bug, and TEST it. Show which actually changed behavior, ranked by severity."</a:t>
             </a:r>
             <a:endParaRPr lang="en-US" sz="1300" dirty="0"/>
           </a:p>
@@ -8825,7 +8825,7 @@
                 <a:ea typeface="Calibri" pitchFamily="34" charset="-122"/>
                 <a:cs typeface="Calibri" pitchFamily="34" charset="-120"/>
               </a:rPr>
-              <a:t>DEMO 08</a:t>
+              <a:t>DEMO 08 · WAYBACK</a:t>
             </a:r>
             <a:endParaRPr lang="en-US" sz="1200" dirty="0"/>
           </a:p>
@@ -8925,7 +8925,7 @@
                 <a:ea typeface="Century Schoolbook" pitchFamily="34" charset="-122"/>
                 <a:cs typeface="Century Schoolbook" pitchFamily="34" charset="-120"/>
               </a:rPr>
-              <a:t>Race conditions / limit bypass</a:t>
+              <a:t>Archive recon → forgotten endpoints</a:t>
             </a:r>
             <a:endParaRPr lang="en-US" sz="3000" dirty="0"/>
           </a:p>
@@ -8968,7 +8968,7 @@
                 <a:ea typeface="Calibri" pitchFamily="34" charset="-122"/>
                 <a:cs typeface="Calibri" pitchFamily="34" charset="-120"/>
               </a:rPr>
-              <a:t>caido_race_window_send: synchronized last-byte copies (single-packet technique)</a:t>
+              <a:t>gau / waybackurls / katana pull thousands of historical URLs</a:t>
             </a:r>
             <a:endParaRPr lang="en-US" sz="1500" dirty="0"/>
           </a:p>
@@ -8989,7 +8989,7 @@
                 <a:ea typeface="Calibri" pitchFamily="34" charset="-122"/>
                 <a:cs typeface="Calibri" pitchFamily="34" charset="-120"/>
               </a:rPr>
-              <a:t>Bypass single-use limits: coupon reuse, double-spend, over-withdraw, invite stuffing</a:t>
+              <a:t>AI triages: old API versions, debug, backups, retired auth</a:t>
             </a:r>
             <a:endParaRPr lang="en-US" sz="1500" dirty="0"/>
           </a:p>
@@ -9010,7 +9010,7 @@
                 <a:ea typeface="Calibri" pitchFamily="34" charset="-122"/>
                 <a:cs typeface="Calibri" pitchFamily="34" charset="-120"/>
               </a:rPr>
-              <a:t>The LLM can't time races — the proxy does it deterministically</a:t>
+              <a:t>caido_batch_send probes the shortlist — still-live, still-sensitive</a:t>
             </a:r>
             <a:endParaRPr lang="en-US" sz="1500" dirty="0"/>
           </a:p>
@@ -9076,7 +9076,7 @@
                 <a:ea typeface="Courier New" pitchFamily="34" charset="-122"/>
                 <a:cs typeface="Courier New" pitchFamily="34" charset="-120"/>
               </a:rPr>
-              <a:t>"Send 20 synchronized last-byte copies of request &lt;ID&gt;; report whether the one-time limit was bypassed."</a:t>
+              <a:t>"Rank these 5,000 archived URLs by bug potential, give me the top 50 to probe in scope, then GET them and flag what's live and sensitive."</a:t>
             </a:r>
             <a:endParaRPr lang="en-US" sz="1300" dirty="0"/>
           </a:p>
@@ -9147,7 +9147,7 @@
                 <a:ea typeface="Calibri" pitchFamily="34" charset="-122"/>
                 <a:cs typeface="Calibri" pitchFamily="34" charset="-120"/>
               </a:rPr>
-              <a:t>DEMO 09</a:t>
+              <a:t>DEMO 09 · GRPC-WEB</a:t>
             </a:r>
             <a:endParaRPr lang="en-US" sz="1200" dirty="0"/>
           </a:p>
@@ -9247,7 +9247,7 @@
                 <a:ea typeface="Century Schoolbook" pitchFamily="34" charset="-122"/>
                 <a:cs typeface="Century Schoolbook" pitchFamily="34" charset="-120"/>
               </a:rPr>
-              <a:t>Mass assignment &amp; hidden authz</a:t>
+              <a:t>Decode &amp; tamper protobuf on a live target</a:t>
             </a:r>
             <a:endParaRPr lang="en-US" sz="3000" dirty="0"/>
           </a:p>
@@ -9290,7 +9290,7 @@
                 <a:ea typeface="Calibri" pitchFamily="34" charset="-122"/>
                 <a:cs typeface="Calibri" pitchFamily="34" charset="-120"/>
               </a:rPr>
-              <a:t>Send fields the UI never shows: role=admin, isAdmin=true, verified=true</a:t>
+              <a:t>gRPC-web / protobuf / batchexecute bodies are opaque binary — most skip them</a:t>
             </a:r>
             <a:endParaRPr lang="en-US" sz="1500" dirty="0"/>
           </a:p>
@@ -9311,7 +9311,7 @@
                 <a:ea typeface="Calibri" pitchFamily="34" charset="-122"/>
                 <a:cs typeface="Calibri" pitchFamily="34" charset="-120"/>
               </a:rPr>
-              <a:t>Probe discovered + inferred admin/debug endpoints with normal and no token</a:t>
+              <a:t>AI reads the app's own JS to recover the message schema</a:t>
             </a:r>
             <a:endParaRPr lang="en-US" sz="1500" dirty="0"/>
           </a:p>
@@ -9332,7 +9332,7 @@
                 <a:ea typeface="Calibri" pitchFamily="34" charset="-122"/>
                 <a:cs typeface="Calibri" pitchFamily="34" charset="-120"/>
               </a:rPr>
-              <a:t>Flows straight out of the demo-04 JS recon (the role field)</a:t>
+              <a:t>Decode → tamper a field → re-encode → test IDOR/authz in Replay</a:t>
             </a:r>
             <a:endParaRPr lang="en-US" sz="1500" dirty="0"/>
           </a:p>
@@ -9398,7 +9398,7 @@
                 <a:ea typeface="Courier New" pitchFamily="34" charset="-122"/>
                 <a:cs typeface="Courier New" pitchFamily="34" charset="-120"/>
               </a:rPr>
-              <a:t>"Add privilege fields the UI never sends; report which the server accepts. Then probe admin/debug endpoints unauth'd."</a:t>
+              <a:t>"Reconstruct the message schema for this RPC from the JS in history, show the decoded body, then re-encode with user_id changed — don't send."</a:t>
             </a:r>
             <a:endParaRPr lang="en-US" sz="1300" dirty="0"/>
           </a:p>
@@ -9469,7 +9469,7 @@
                 <a:ea typeface="Calibri" pitchFamily="34" charset="-122"/>
                 <a:cs typeface="Calibri" pitchFamily="34" charset="-120"/>
               </a:rPr>
-              <a:t>DEMO 10</a:t>
+              <a:t>DEMO 10 · GRAPHQL-ANALYZER</a:t>
             </a:r>
             <a:endParaRPr lang="en-US" sz="1200" dirty="0"/>
           </a:p>
@@ -9492,7 +9492,7 @@
             </a:avLst>
           </a:prstGeom>
           <a:solidFill>
-            <a:srgbClr val="3FB950"/>
+            <a:srgbClr val="F85149"/>
           </a:solidFill>
           <a:ln/>
         </p:spPr>
@@ -9530,7 +9530,7 @@
                 <a:ea typeface="Calibri" pitchFamily="34" charset="-122"/>
                 <a:cs typeface="Calibri" pitchFamily="34" charset="-120"/>
               </a:rPr>
-              <a:t>SURFACE</a:t>
+              <a:t>CRITICAL</a:t>
             </a:r>
             <a:endParaRPr lang="en-US" sz="1300" dirty="0"/>
           </a:p>
@@ -9569,7 +9569,7 @@
                 <a:ea typeface="Century Schoolbook" pitchFamily="34" charset="-122"/>
                 <a:cs typeface="Century Schoolbook" pitchFamily="34" charset="-120"/>
               </a:rPr>
-              <a:t>GraphQL / gRPC recon</a:t>
+              <a:t>GraphQL assault</a:t>
             </a:r>
             <a:endParaRPr lang="en-US" sz="3000" dirty="0"/>
           </a:p>
@@ -9612,7 +9612,7 @@
                 <a:ea typeface="Calibri" pitchFamily="34" charset="-122"/>
                 <a:cs typeface="Calibri" pitchFamily="34" charset="-120"/>
               </a:rPr>
-              <a:t>Reverse opaque batchexecute?rpcids=… from the app's own JS in Caido</a:t>
+              <a:t>Plugin maps the schema (introspection or inferred)</a:t>
             </a:r>
             <a:endParaRPr lang="en-US" sz="1500" dirty="0"/>
           </a:p>
@@ -9633,7 +9633,7 @@
                 <a:ea typeface="Calibri" pitchFamily="34" charset="-122"/>
                 <a:cs typeface="Calibri" pitchFamily="34" charset="-120"/>
               </a:rPr>
-              <a:t>Reconstruct GraphQL schema when introspection is disabled</a:t>
+              <a:t>AI picks the dangerous mutations + IDOR-shaped queries from hundreds of types</a:t>
             </a:r>
             <a:endParaRPr lang="en-US" sz="1500" dirty="0"/>
           </a:p>
@@ -9654,7 +9654,7 @@
                 <a:ea typeface="Calibri" pitchFamily="34" charset="-122"/>
                 <a:cs typeface="Calibri" pitchFamily="34" charset="-120"/>
               </a:rPr>
-              <a:t>Then bake the repeatable part into a deterministic Caido plugin</a:t>
+              <a:t>Tests authz, node(id:) IDOR, and alias/batch rate-limit bypass</a:t>
             </a:r>
             <a:endParaRPr lang="en-US" sz="1500" dirty="0"/>
           </a:p>
@@ -9720,7 +9720,7 @@
                 <a:ea typeface="Courier New" pitchFamily="34" charset="-122"/>
                 <a:cs typeface="Courier New" pitchFamily="34" charset="-120"/>
               </a:rPr>
-              <a:t>"Reverse the rpcids request from the JS in caido history; draft a markdown report. Then build a plugin to map rpcids → RPC name."</a:t>
+              <a:t>"List state-changing + cross-user mutations and IDOR-candidate queries, then craft GraphQL to prove IDOR and aliased-batch rate-limit bypass."</a:t>
             </a:r>
             <a:endParaRPr lang="en-US" sz="1300" dirty="0"/>
           </a:p>
@@ -10037,7 +10037,7 @@
         <p:spPr>
           <a:xfrm>
             <a:off x="640080" y="2103120"/>
-            <a:ext cx="10789920" cy="3200400"/>
+            <a:ext cx="10789920" cy="3474720"/>
           </a:xfrm>
           <a:prstGeom prst="rect">
             <a:avLst/>
@@ -10051,13 +10051,13 @@
           <a:p>
             <a:pPr marL="190500" indent="-190500">
               <a:spcAft>
-                <a:spcPts val="1400"/>
+                <a:spcPts val="1200"/>
               </a:spcAft>
               <a:buSzPct val="100000"/>
               <a:buChar char="•"/>
             </a:pPr>
             <a:r>
-              <a:rPr lang="en-US" sz="1700" dirty="0">
+              <a:rPr lang="en-US" sz="1500" dirty="0">
                 <a:solidFill>
                   <a:srgbClr val="11161D"/>
                 </a:solidFill>
@@ -10067,18 +10067,18 @@
               </a:rPr>
               <a:t>github.com/jaiswalakshansh/caido-ai-workshop  (this repo)</a:t>
             </a:r>
-            <a:endParaRPr lang="en-US" sz="1700" dirty="0"/>
+            <a:endParaRPr lang="en-US" sz="1500" dirty="0"/>
           </a:p>
           <a:p>
             <a:pPr marL="190500" indent="-190500">
               <a:spcAft>
-                <a:spcPts val="1400"/>
+                <a:spcPts val="1200"/>
               </a:spcAft>
               <a:buSzPct val="100000"/>
               <a:buChar char="•"/>
             </a:pPr>
             <a:r>
-              <a:rPr lang="en-US" sz="1700" dirty="0">
+              <a:rPr lang="en-US" sz="1500" dirty="0">
                 <a:solidFill>
                   <a:srgbClr val="11161D"/>
                 </a:solidFill>
@@ -10088,18 +10088,18 @@
               </a:rPr>
               <a:t>github.com/caido/skills  ·  github.com/c0tton-fluff/caido-mcp-server</a:t>
             </a:r>
-            <a:endParaRPr lang="en-US" sz="1700" dirty="0"/>
+            <a:endParaRPr lang="en-US" sz="1500" dirty="0"/>
           </a:p>
           <a:p>
             <a:pPr marL="190500" indent="-190500">
               <a:spcAft>
-                <a:spcPts val="1400"/>
+                <a:spcPts val="1200"/>
               </a:spcAft>
               <a:buSzPct val="100000"/>
               <a:buChar char="•"/>
             </a:pPr>
             <a:r>
-              <a:rPr lang="en-US" sz="1700" dirty="0">
+              <a:rPr lang="en-US" sz="1500" dirty="0">
                 <a:solidFill>
                   <a:srgbClr val="11161D"/>
                 </a:solidFill>
@@ -10107,20 +10107,20 @@
                 <a:ea typeface="Courier New" pitchFamily="34" charset="-122"/>
                 <a:cs typeface="Courier New" pitchFamily="34" charset="-120"/>
               </a:rPr>
-              <a:t>github.com/caido-community/quickssrf  ·  github.com/vitorfhc/caido-rpc-mapper</a:t>
-            </a:r>
-            <a:endParaRPr lang="en-US" sz="1700" dirty="0"/>
+              <a:t>Plugins: caido-community/ — authmatrix · ParamFinder · GraphQL-Analyzer</a:t>
+            </a:r>
+            <a:endParaRPr lang="en-US" sz="1500" dirty="0"/>
           </a:p>
           <a:p>
             <a:pPr marL="190500" indent="-190500">
               <a:spcAft>
-                <a:spcPts val="1400"/>
+                <a:spcPts val="1200"/>
               </a:spcAft>
               <a:buSzPct val="100000"/>
               <a:buChar char="•"/>
             </a:pPr>
             <a:r>
-              <a:rPr lang="en-US" sz="1700" dirty="0">
+              <a:rPr lang="en-US" sz="1500" dirty="0">
                 <a:solidFill>
                   <a:srgbClr val="11161D"/>
                 </a:solidFill>
@@ -10128,9 +10128,30 @@
                 <a:ea typeface="Courier New" pitchFamily="34" charset="-122"/>
                 <a:cs typeface="Courier New" pitchFamily="34" charset="-120"/>
               </a:rPr>
-              <a:t>labs.trace37.com/blog/caido-ai-hunting-platform</a:t>
-            </a:r>
-            <a:endParaRPr lang="en-US" sz="1700" dirty="0"/>
+              <a:t>          JS-Analyzer · quickssrf · crawler · scanner · JWT-Analyzer</a:t>
+            </a:r>
+            <a:endParaRPr lang="en-US" sz="1500" dirty="0"/>
+          </a:p>
+          <a:p>
+            <a:pPr marL="190500" indent="-190500">
+              <a:spcAft>
+                <a:spcPts val="1200"/>
+              </a:spcAft>
+              <a:buSzPct val="100000"/>
+              <a:buChar char="•"/>
+            </a:pPr>
+            <a:r>
+              <a:rPr lang="en-US" sz="1500" dirty="0">
+                <a:solidFill>
+                  <a:srgbClr val="11161D"/>
+                </a:solidFill>
+                <a:latin typeface="Courier New" pitchFamily="34" charset="0"/>
+                <a:ea typeface="Courier New" pitchFamily="34" charset="-122"/>
+                <a:cs typeface="Courier New" pitchFamily="34" charset="-120"/>
+              </a:rPr>
+              <a:t>github.com/vitorfhc/caido-rpc-mapper  ·  labs.trace37.com/blog/caido-ai-hunting-platform</a:t>
+            </a:r>
+            <a:endParaRPr lang="en-US" sz="1500" dirty="0"/>
           </a:p>
         </p:txBody>
       </p:sp>

</xml_diff>

<commit_message>
slides: add QR code to the repo on the title slide
</commit_message>
<xml_diff>
--- a/slides/your-ai-needs-a-proxy.pptx
+++ b/slides/your-ai-needs-a-proxy.pptx
@@ -528,7 +528,7 @@
           <a:p>
             <a:r>
               <a:rPr lang="en-US" dirty="0"/>
-              <a:t>Hook: everyone's letting AI fire blind curl at targets. Let's make it observable, safe, and actually good at finding bugs.</a:t>
+              <a:t>Hook: everyone's letting AI fire blind curl at targets. Let's make it observable, safe, and actually good at finding bugs. Point out the QR for the repo.</a:t>
             </a:r>
             <a:endParaRPr lang="en-US" dirty="0"/>
           </a:p>
@@ -3398,7 +3398,7 @@
         <p:spPr>
           <a:xfrm>
             <a:off x="640080" y="6035040"/>
-            <a:ext cx="10058400" cy="365760"/>
+            <a:ext cx="7315200" cy="365760"/>
           </a:xfrm>
           <a:prstGeom prst="rect">
             <a:avLst/>
@@ -3425,6 +3425,130 @@
               <a:t>Claude Code  ·  MCP &amp; Skills  ·  real critical/high bugs</a:t>
             </a:r>
             <a:endParaRPr lang="en-US" sz="1300" dirty="0"/>
+          </a:p>
+        </p:txBody>
+      </p:sp>
+      <p:sp>
+        <p:nvSpPr>
+          <p:cNvPr id="7" name="Shape 5"/>
+          <p:cNvSpPr/>
+          <p:nvPr/>
+        </p:nvSpPr>
+        <p:spPr>
+          <a:xfrm>
+            <a:off x="9208008" y="1755648"/>
+            <a:ext cx="2386584" cy="2386584"/>
+          </a:xfrm>
+          <a:prstGeom prst="roundRect">
+            <a:avLst>
+              <a:gd name="adj" fmla="val 3065"/>
+            </a:avLst>
+          </a:prstGeom>
+          <a:solidFill>
+            <a:srgbClr val="FFFFFF"/>
+          </a:solidFill>
+          <a:ln/>
+        </p:spPr>
+      </p:sp>
+      <p:pic>
+        <p:nvPicPr>
+          <p:cNvPr id="8" name="Image 0" descr="assets-qr.png">    </p:cNvPr>
+          <p:cNvPicPr>
+            <a:picLocks noChangeAspect="1"/>
+          </p:cNvPicPr>
+          <p:nvPr/>
+        </p:nvPicPr>
+        <p:blipFill>
+          <a:blip r:embed="rId1"/>
+          <a:stretch>
+            <a:fillRect/>
+          </a:stretch>
+        </p:blipFill>
+        <p:spPr>
+          <a:xfrm>
+            <a:off x="9372600" y="1920240"/>
+            <a:ext cx="2057400" cy="2057400"/>
+          </a:xfrm>
+          <a:prstGeom prst="rect">
+            <a:avLst/>
+          </a:prstGeom>
+        </p:spPr>
+      </p:pic>
+      <p:sp>
+        <p:nvSpPr>
+          <p:cNvPr id="9" name="Text 6"/>
+          <p:cNvSpPr txBox="1"/>
+          <p:nvPr/>
+        </p:nvSpPr>
+        <p:spPr>
+          <a:xfrm>
+            <a:off x="9006840" y="4233672"/>
+            <a:ext cx="3063240" cy="320040"/>
+          </a:xfrm>
+          <a:prstGeom prst="rect">
+            <a:avLst/>
+          </a:prstGeom>
+          <a:noFill/>
+          <a:ln/>
+        </p:spPr>
+        <p:txBody>
+          <a:bodyPr wrap="square" lIns="0" tIns="0" rIns="0" bIns="0" rtlCol="0" anchor="ctr"/>
+          <a:lstStyle/>
+          <a:p>
+            <a:pPr algn="ctr" indent="0" marL="0">
+              <a:buNone/>
+            </a:pPr>
+            <a:r>
+              <a:rPr lang="en-US" sz="1200" b="1" dirty="0">
+                <a:solidFill>
+                  <a:srgbClr val="E6EDF3"/>
+                </a:solidFill>
+                <a:latin typeface="Calibri" pitchFamily="34" charset="0"/>
+                <a:ea typeface="Calibri" pitchFamily="34" charset="-122"/>
+                <a:cs typeface="Calibri" pitchFamily="34" charset="-120"/>
+              </a:rPr>
+              <a:t>Scan → the workshop repo</a:t>
+            </a:r>
+            <a:endParaRPr lang="en-US" sz="1200" dirty="0"/>
+          </a:p>
+        </p:txBody>
+      </p:sp>
+      <p:sp>
+        <p:nvSpPr>
+          <p:cNvPr id="10" name="Text 7"/>
+          <p:cNvSpPr txBox="1"/>
+          <p:nvPr/>
+        </p:nvSpPr>
+        <p:spPr>
+          <a:xfrm>
+            <a:off x="8823960" y="4526280"/>
+            <a:ext cx="3429000" cy="320040"/>
+          </a:xfrm>
+          <a:prstGeom prst="rect">
+            <a:avLst/>
+          </a:prstGeom>
+          <a:noFill/>
+          <a:ln/>
+        </p:spPr>
+        <p:txBody>
+          <a:bodyPr wrap="square" lIns="0" tIns="0" rIns="0" bIns="0" rtlCol="0" anchor="ctr"/>
+          <a:lstStyle/>
+          <a:p>
+            <a:pPr algn="ctr" indent="0" marL="0">
+              <a:buNone/>
+            </a:pPr>
+            <a:r>
+              <a:rPr lang="en-US" sz="900" dirty="0">
+                <a:solidFill>
+                  <a:srgbClr val="8B949E"/>
+                </a:solidFill>
+                <a:latin typeface="Courier New" pitchFamily="34" charset="0"/>
+                <a:ea typeface="Courier New" pitchFamily="34" charset="-122"/>
+                <a:cs typeface="Courier New" pitchFamily="34" charset="-120"/>
+              </a:rPr>
+              <a:t>github.com/jaiswalakshansh/caido-ai-workshop</a:t>
+            </a:r>
+            <a:endParaRPr lang="en-US" sz="900" dirty="0"/>
           </a:p>
         </p:txBody>
       </p:sp>

</xml_diff>